<commit_message>
Revise site navigation, content, and product presentation.
Consolidate science content pages, add the probiotics medical page, refresh key copy and imagery, and update product pricing/promo details for the latest launch messaging.

Co-authored-by: Cursor <cursoragent@cursor.com>
</commit_message>
<xml_diff>
--- a/logo設計.pptx
+++ b/logo設計.pptx
@@ -6,6 +6,7 @@
   </p:sldMasterIdLst>
   <p:sldIdLst>
     <p:sldId id="256" r:id="rId2"/>
+    <p:sldId id="257" r:id="rId3"/>
   </p:sldIdLst>
   <p:sldSz cx="12192000" cy="6858000"/>
   <p:notesSz cx="6858000" cy="9144000"/>
@@ -104,6 +105,11 @@
       </a:defRPr>
     </a:lvl9pPr>
   </p:defaultTextStyle>
+  <p:extLst>
+    <p:ext uri="{EFAFB233-063F-42B5-8137-9DF3F51BA10A}">
+      <p15:sldGuideLst xmlns:p15="http://schemas.microsoft.com/office/powerpoint/2012/main"/>
+    </p:ext>
+  </p:extLst>
 </p:presentation>
 </file>
 
@@ -254,7 +260,7 @@
           <a:p>
             <a:fld id="{3E28327F-5582-4A11-AE40-18A3B9340FB4}" type="datetimeFigureOut">
               <a:rPr lang="zh-TW" altLang="en-US" smtClean="0"/>
-              <a:t>2026/4/26</a:t>
+              <a:t>2026/5/12</a:t>
             </a:fld>
             <a:endParaRPr lang="zh-TW" altLang="en-US"/>
           </a:p>
@@ -452,7 +458,7 @@
           <a:p>
             <a:fld id="{3E28327F-5582-4A11-AE40-18A3B9340FB4}" type="datetimeFigureOut">
               <a:rPr lang="zh-TW" altLang="en-US" smtClean="0"/>
-              <a:t>2026/4/26</a:t>
+              <a:t>2026/5/12</a:t>
             </a:fld>
             <a:endParaRPr lang="zh-TW" altLang="en-US"/>
           </a:p>
@@ -660,7 +666,7 @@
           <a:p>
             <a:fld id="{3E28327F-5582-4A11-AE40-18A3B9340FB4}" type="datetimeFigureOut">
               <a:rPr lang="zh-TW" altLang="en-US" smtClean="0"/>
-              <a:t>2026/4/26</a:t>
+              <a:t>2026/5/12</a:t>
             </a:fld>
             <a:endParaRPr lang="zh-TW" altLang="en-US"/>
           </a:p>
@@ -858,7 +864,7 @@
           <a:p>
             <a:fld id="{3E28327F-5582-4A11-AE40-18A3B9340FB4}" type="datetimeFigureOut">
               <a:rPr lang="zh-TW" altLang="en-US" smtClean="0"/>
-              <a:t>2026/4/26</a:t>
+              <a:t>2026/5/12</a:t>
             </a:fld>
             <a:endParaRPr lang="zh-TW" altLang="en-US"/>
           </a:p>
@@ -1133,7 +1139,7 @@
           <a:p>
             <a:fld id="{3E28327F-5582-4A11-AE40-18A3B9340FB4}" type="datetimeFigureOut">
               <a:rPr lang="zh-TW" altLang="en-US" smtClean="0"/>
-              <a:t>2026/4/26</a:t>
+              <a:t>2026/5/12</a:t>
             </a:fld>
             <a:endParaRPr lang="zh-TW" altLang="en-US"/>
           </a:p>
@@ -1398,7 +1404,7 @@
           <a:p>
             <a:fld id="{3E28327F-5582-4A11-AE40-18A3B9340FB4}" type="datetimeFigureOut">
               <a:rPr lang="zh-TW" altLang="en-US" smtClean="0"/>
-              <a:t>2026/4/26</a:t>
+              <a:t>2026/5/12</a:t>
             </a:fld>
             <a:endParaRPr lang="zh-TW" altLang="en-US"/>
           </a:p>
@@ -1810,7 +1816,7 @@
           <a:p>
             <a:fld id="{3E28327F-5582-4A11-AE40-18A3B9340FB4}" type="datetimeFigureOut">
               <a:rPr lang="zh-TW" altLang="en-US" smtClean="0"/>
-              <a:t>2026/4/26</a:t>
+              <a:t>2026/5/12</a:t>
             </a:fld>
             <a:endParaRPr lang="zh-TW" altLang="en-US"/>
           </a:p>
@@ -1951,7 +1957,7 @@
           <a:p>
             <a:fld id="{3E28327F-5582-4A11-AE40-18A3B9340FB4}" type="datetimeFigureOut">
               <a:rPr lang="zh-TW" altLang="en-US" smtClean="0"/>
-              <a:t>2026/4/26</a:t>
+              <a:t>2026/5/12</a:t>
             </a:fld>
             <a:endParaRPr lang="zh-TW" altLang="en-US"/>
           </a:p>
@@ -2064,7 +2070,7 @@
           <a:p>
             <a:fld id="{3E28327F-5582-4A11-AE40-18A3B9340FB4}" type="datetimeFigureOut">
               <a:rPr lang="zh-TW" altLang="en-US" smtClean="0"/>
-              <a:t>2026/4/26</a:t>
+              <a:t>2026/5/12</a:t>
             </a:fld>
             <a:endParaRPr lang="zh-TW" altLang="en-US"/>
           </a:p>
@@ -2375,7 +2381,7 @@
           <a:p>
             <a:fld id="{3E28327F-5582-4A11-AE40-18A3B9340FB4}" type="datetimeFigureOut">
               <a:rPr lang="zh-TW" altLang="en-US" smtClean="0"/>
-              <a:t>2026/4/26</a:t>
+              <a:t>2026/5/12</a:t>
             </a:fld>
             <a:endParaRPr lang="zh-TW" altLang="en-US"/>
           </a:p>
@@ -2663,7 +2669,7 @@
           <a:p>
             <a:fld id="{3E28327F-5582-4A11-AE40-18A3B9340FB4}" type="datetimeFigureOut">
               <a:rPr lang="zh-TW" altLang="en-US" smtClean="0"/>
-              <a:t>2026/4/26</a:t>
+              <a:t>2026/5/12</a:t>
             </a:fld>
             <a:endParaRPr lang="zh-TW" altLang="en-US"/>
           </a:p>
@@ -2904,7 +2910,7 @@
           <a:p>
             <a:fld id="{3E28327F-5582-4A11-AE40-18A3B9340FB4}" type="datetimeFigureOut">
               <a:rPr lang="zh-TW" altLang="en-US" smtClean="0"/>
-              <a:t>2026/4/26</a:t>
+              <a:t>2026/5/12</a:t>
             </a:fld>
             <a:endParaRPr lang="zh-TW" altLang="en-US"/>
           </a:p>
@@ -3556,6 +3562,110 @@
 </p:sld>
 </file>
 
+<file path=ppt/slides/slide2.xml><?xml version="1.0" encoding="utf-8"?>
+<p:sld xmlns:a="http://schemas.openxmlformats.org/drawingml/2006/main" xmlns:r="http://schemas.openxmlformats.org/officeDocument/2006/relationships" xmlns:p="http://schemas.openxmlformats.org/presentationml/2006/main">
+  <p:cSld>
+    <p:spTree>
+      <p:nvGrpSpPr>
+        <p:cNvPr id="1" name=""/>
+        <p:cNvGrpSpPr/>
+        <p:nvPr/>
+      </p:nvGrpSpPr>
+      <p:grpSpPr>
+        <a:xfrm>
+          <a:off x="0" y="0"/>
+          <a:ext cx="0" cy="0"/>
+          <a:chOff x="0" y="0"/>
+          <a:chExt cx="0" cy="0"/>
+        </a:xfrm>
+      </p:grpSpPr>
+      <p:pic>
+        <p:nvPicPr>
+          <p:cNvPr id="5" name="圖片 4">
+            <a:extLst>
+              <a:ext uri="{FF2B5EF4-FFF2-40B4-BE49-F238E27FC236}">
+                <a16:creationId xmlns:a16="http://schemas.microsoft.com/office/drawing/2014/main" id="{4E356681-BF59-0EAE-5177-7766BE11E6F4}"/>
+              </a:ext>
+            </a:extLst>
+          </p:cNvPr>
+          <p:cNvPicPr>
+            <a:picLocks noChangeAspect="1"/>
+          </p:cNvPicPr>
+          <p:nvPr/>
+        </p:nvPicPr>
+        <p:blipFill>
+          <a:blip r:embed="rId2">
+            <a:extLst>
+              <a:ext uri="{28A0092B-C50C-407E-A947-70E740481C1C}">
+                <a14:useLocalDpi xmlns:a14="http://schemas.microsoft.com/office/drawing/2010/main" val="0"/>
+              </a:ext>
+            </a:extLst>
+          </a:blip>
+          <a:srcRect l="10946"/>
+          <a:stretch>
+            <a:fillRect/>
+          </a:stretch>
+        </p:blipFill>
+        <p:spPr>
+          <a:xfrm>
+            <a:off x="2028825" y="447675"/>
+            <a:ext cx="3477768" cy="5962650"/>
+          </a:xfrm>
+          <a:prstGeom prst="rect">
+            <a:avLst/>
+          </a:prstGeom>
+        </p:spPr>
+      </p:pic>
+      <p:pic>
+        <p:nvPicPr>
+          <p:cNvPr id="6" name="圖片 5">
+            <a:extLst>
+              <a:ext uri="{FF2B5EF4-FFF2-40B4-BE49-F238E27FC236}">
+                <a16:creationId xmlns:a16="http://schemas.microsoft.com/office/drawing/2014/main" id="{2B143695-0EE8-7474-296F-D79D3ACF6286}"/>
+              </a:ext>
+            </a:extLst>
+          </p:cNvPr>
+          <p:cNvPicPr>
+            <a:picLocks noChangeAspect="1"/>
+          </p:cNvPicPr>
+          <p:nvPr/>
+        </p:nvPicPr>
+        <p:blipFill>
+          <a:blip r:embed="rId2">
+            <a:extLst>
+              <a:ext uri="{28A0092B-C50C-407E-A947-70E740481C1C}">
+                <a14:useLocalDpi xmlns:a14="http://schemas.microsoft.com/office/drawing/2010/main" val="0"/>
+              </a:ext>
+            </a:extLst>
+          </a:blip>
+          <a:srcRect r="11769"/>
+          <a:stretch>
+            <a:fillRect/>
+          </a:stretch>
+        </p:blipFill>
+        <p:spPr>
+          <a:xfrm>
+            <a:off x="4179951" y="1427876"/>
+            <a:ext cx="2879217" cy="4982449"/>
+          </a:xfrm>
+          <a:prstGeom prst="rect">
+            <a:avLst/>
+          </a:prstGeom>
+        </p:spPr>
+      </p:pic>
+    </p:spTree>
+    <p:extLst>
+      <p:ext uri="{BB962C8B-B14F-4D97-AF65-F5344CB8AC3E}">
+        <p14:creationId xmlns:p14="http://schemas.microsoft.com/office/powerpoint/2010/main" val="2103893426"/>
+      </p:ext>
+    </p:extLst>
+  </p:cSld>
+  <p:clrMapOvr>
+    <a:masterClrMapping/>
+  </p:clrMapOvr>
+</p:sld>
+</file>
+
 <file path=ppt/theme/theme1.xml><?xml version="1.0" encoding="utf-8"?>
 <a:theme xmlns:a="http://schemas.openxmlformats.org/drawingml/2006/main" name="Office 佈景主題">
   <a:themeElements>

</xml_diff>